<commit_message>
Show distinct website and app pages in role slides
</commit_message>
<xml_diff>
--- a/presentation/Lawyer-Firm-Pitch.pptx
+++ b/presentation/Lawyer-Firm-Pitch.pptx
@@ -8777,7 +8777,7 @@
                 <a:ea typeface="Arial" pitchFamily="34" charset="-122"/>
                 <a:cs typeface="Arial" pitchFamily="34" charset="-120"/>
               </a:rPr>
-              <a:t>WEBSITE</a:t>
+              <a:t>WEBSITE · CONSULTATIONS</a:t>
             </a:r>
             <a:endParaRPr lang="en-US" sz="1100" dirty="0"/>
           </a:p>
@@ -8792,7 +8792,7 @@
         <p:spPr>
           <a:xfrm>
             <a:off x="9052560" y="1645920"/>
-            <a:ext cx="2148840" cy="228600"/>
+            <a:ext cx="2468880" cy="228600"/>
           </a:xfrm>
           <a:prstGeom prst="rect">
             <a:avLst/>
@@ -8816,7 +8816,7 @@
                 <a:ea typeface="Arial" pitchFamily="34" charset="-122"/>
                 <a:cs typeface="Arial" pitchFamily="34" charset="-120"/>
               </a:rPr>
-              <a:t>APP PREVIEW</a:t>
+              <a:t>APP · OVERVIEW</a:t>
             </a:r>
             <a:endParaRPr lang="en-US" sz="1100" dirty="0"/>
           </a:p>
@@ -9882,7 +9882,7 @@
                 <a:ea typeface="Arial" pitchFamily="34" charset="-122"/>
                 <a:cs typeface="Arial" pitchFamily="34" charset="-120"/>
               </a:rPr>
-              <a:t>WEBSITE</a:t>
+              <a:t>WEBSITE · SCHEDULE</a:t>
             </a:r>
             <a:endParaRPr lang="en-US" sz="1100" dirty="0"/>
           </a:p>
@@ -9897,7 +9897,7 @@
         <p:spPr>
           <a:xfrm>
             <a:off x="9052560" y="1645920"/>
-            <a:ext cx="2148840" cy="228600"/>
+            <a:ext cx="2468880" cy="228600"/>
           </a:xfrm>
           <a:prstGeom prst="rect">
             <a:avLst/>
@@ -9921,7 +9921,7 @@
                 <a:ea typeface="Arial" pitchFamily="34" charset="-122"/>
                 <a:cs typeface="Arial" pitchFamily="34" charset="-120"/>
               </a:rPr>
-              <a:t>APP PREVIEW</a:t>
+              <a:t>APP · AVAILABILITY</a:t>
             </a:r>
             <a:endParaRPr lang="en-US" sz="1100" dirty="0"/>
           </a:p>
@@ -10945,7 +10945,7 @@
                 <a:ea typeface="Arial" pitchFamily="34" charset="-122"/>
                 <a:cs typeface="Arial" pitchFamily="34" charset="-120"/>
               </a:rPr>
-              <a:t>WEBSITE</a:t>
+              <a:t>WEBSITE · INSIGHTS</a:t>
             </a:r>
             <a:endParaRPr lang="en-US" sz="1100" dirty="0"/>
           </a:p>
@@ -10960,7 +10960,7 @@
         <p:spPr>
           <a:xfrm>
             <a:off x="9052560" y="1645920"/>
-            <a:ext cx="2148840" cy="228600"/>
+            <a:ext cx="2468880" cy="228600"/>
           </a:xfrm>
           <a:prstGeom prst="rect">
             <a:avLst/>
@@ -10984,7 +10984,7 @@
                 <a:ea typeface="Arial" pitchFamily="34" charset="-122"/>
                 <a:cs typeface="Arial" pitchFamily="34" charset="-120"/>
               </a:rPr>
-              <a:t>APP PREVIEW</a:t>
+              <a:t>APP · LAWYERS</a:t>
             </a:r>
             <a:endParaRPr lang="en-US" sz="1100" dirty="0"/>
           </a:p>

</xml_diff>